<commit_message>
Clarify audited bilingual CSE513 concepts and synchronize decks
</commit_message>
<xml_diff>
--- a/public/study/cse513/downloads/week-02.pptx
+++ b/public/study/cse513/downloads/week-02.pptx
@@ -3711,7 +3711,12 @@
           </a:p>
           <a:p xmlns:a="http://schemas.openxmlformats.org/drawingml/2006/main">
             <a:r>
-              <a:t>SORUNUN YANITI: 1 P1 SRTF’de R0,W9.2 SJF optimal iddiası birlikte available,known bursts,zero overhead.3 Endpoint arrivals before current requeue; alternatif sonuç değişir.4 RM bound geçmezse inconclusive; Example B actual miss.5 EDF U≤1 sadece independent preemptible single CPU D=T modelinde.6 Affinity placement restriction; reservation değil. SMT bağımsız core guarantee değil; EEVDF virtual deadline application deadline değil.</a:t>
+              <a:t>SORUNUN YANITI: 1) P1 için SRTF’de R=0, W=9.
+2) SJF’nin ortalama bekleme için optimal olduğu iddiası; işlerin birlikte hazır olmasını, CPU burst sürelerinin bilinmesini ve sıfır ek maliyeti varsayar.
+3) Quantum sınırındaki arrivals, mevcut iş yeniden kuyruğa konmadan eklenir; farklı kural sonucu değiştirebilir.
+4) RM yeterli testi geçmezse sonuç belirsizdir; B örneğinde ise gerçekten deadline kaçırılır.
+5) EDF için U≤1 garantisi bağımsız, preemptible işler, tek CPU ve D=T modeline aittir.
+6) Affinity yerleşimi sınırlar; özel CPU kullanımını garanti etmez. SMT bağımsız core kapasitesi garanti etmez. EEVDF virtual deadline, uygulamanın deadline’ı değildir.</a:t>
             </a:r>
           </a:p>
           <a:p xmlns:a="http://schemas.openxmlformats.org/drawingml/2006/main">

</xml_diff>